<commit_message>
Updates slides and structure.
</commit_message>
<xml_diff>
--- a/slides/00_course_intro.pptx
+++ b/slides/00_course_intro.pptx
@@ -3284,7 +3284,7 @@
           <a:p>
             <a:fld id="{3E22BF2E-04DA-469E-97C5-BB68A0368813}" type="datetimeFigureOut">
               <a:rPr lang="en-US" smtClean="0"/>
-              <a:t>3/30/2026</a:t>
+              <a:t>4/9/2026</a:t>
             </a:fld>
             <a:endParaRPr lang="en-US"/>
           </a:p>
@@ -3482,7 +3482,7 @@
           <a:p>
             <a:fld id="{3E22BF2E-04DA-469E-97C5-BB68A0368813}" type="datetimeFigureOut">
               <a:rPr lang="en-US" smtClean="0"/>
-              <a:t>3/30/2026</a:t>
+              <a:t>4/9/2026</a:t>
             </a:fld>
             <a:endParaRPr lang="en-US"/>
           </a:p>
@@ -3690,7 +3690,7 @@
           <a:p>
             <a:fld id="{3E22BF2E-04DA-469E-97C5-BB68A0368813}" type="datetimeFigureOut">
               <a:rPr lang="en-US" smtClean="0"/>
-              <a:t>3/30/2026</a:t>
+              <a:t>4/9/2026</a:t>
             </a:fld>
             <a:endParaRPr lang="en-US"/>
           </a:p>
@@ -3898,7 +3898,7 @@
           <a:p>
             <a:fld id="{3E22BF2E-04DA-469E-97C5-BB68A0368813}" type="datetimeFigureOut">
               <a:rPr lang="en-US" smtClean="0"/>
-              <a:t>3/30/2026</a:t>
+              <a:t>4/9/2026</a:t>
             </a:fld>
             <a:endParaRPr lang="en-US"/>
           </a:p>
@@ -4173,7 +4173,7 @@
           <a:p>
             <a:fld id="{3E22BF2E-04DA-469E-97C5-BB68A0368813}" type="datetimeFigureOut">
               <a:rPr lang="en-US" smtClean="0"/>
-              <a:t>3/30/2026</a:t>
+              <a:t>4/9/2026</a:t>
             </a:fld>
             <a:endParaRPr lang="en-US"/>
           </a:p>
@@ -4438,7 +4438,7 @@
           <a:p>
             <a:fld id="{3E22BF2E-04DA-469E-97C5-BB68A0368813}" type="datetimeFigureOut">
               <a:rPr lang="en-US" smtClean="0"/>
-              <a:t>3/30/2026</a:t>
+              <a:t>4/9/2026</a:t>
             </a:fld>
             <a:endParaRPr lang="en-US"/>
           </a:p>
@@ -4850,7 +4850,7 @@
           <a:p>
             <a:fld id="{3E22BF2E-04DA-469E-97C5-BB68A0368813}" type="datetimeFigureOut">
               <a:rPr lang="en-US" smtClean="0"/>
-              <a:t>3/30/2026</a:t>
+              <a:t>4/9/2026</a:t>
             </a:fld>
             <a:endParaRPr lang="en-US"/>
           </a:p>
@@ -4991,7 +4991,7 @@
           <a:p>
             <a:fld id="{3E22BF2E-04DA-469E-97C5-BB68A0368813}" type="datetimeFigureOut">
               <a:rPr lang="en-US" smtClean="0"/>
-              <a:t>3/30/2026</a:t>
+              <a:t>4/9/2026</a:t>
             </a:fld>
             <a:endParaRPr lang="en-US"/>
           </a:p>
@@ -5104,7 +5104,7 @@
           <a:p>
             <a:fld id="{3E22BF2E-04DA-469E-97C5-BB68A0368813}" type="datetimeFigureOut">
               <a:rPr lang="en-US" smtClean="0"/>
-              <a:t>3/30/2026</a:t>
+              <a:t>4/9/2026</a:t>
             </a:fld>
             <a:endParaRPr lang="en-US"/>
           </a:p>
@@ -5415,7 +5415,7 @@
           <a:p>
             <a:fld id="{3E22BF2E-04DA-469E-97C5-BB68A0368813}" type="datetimeFigureOut">
               <a:rPr lang="en-US" smtClean="0"/>
-              <a:t>3/30/2026</a:t>
+              <a:t>4/9/2026</a:t>
             </a:fld>
             <a:endParaRPr lang="en-US"/>
           </a:p>
@@ -5703,7 +5703,7 @@
           <a:p>
             <a:fld id="{3E22BF2E-04DA-469E-97C5-BB68A0368813}" type="datetimeFigureOut">
               <a:rPr lang="en-US" smtClean="0"/>
-              <a:t>3/30/2026</a:t>
+              <a:t>4/9/2026</a:t>
             </a:fld>
             <a:endParaRPr lang="en-US"/>
           </a:p>
@@ -5944,7 +5944,7 @@
           <a:p>
             <a:fld id="{3E22BF2E-04DA-469E-97C5-BB68A0368813}" type="datetimeFigureOut">
               <a:rPr lang="en-US" smtClean="0"/>
-              <a:t>3/30/2026</a:t>
+              <a:t>4/9/2026</a:t>
             </a:fld>
             <a:endParaRPr lang="en-US"/>
           </a:p>
@@ -8338,7 +8338,19 @@
           <a:p>
             <a:r>
               <a:rPr lang="en-US" sz="4600"/>
-              <a:t>To Be Successful you need…</a:t>
+              <a:t>To Be Successful You </a:t>
+            </a:r>
+            <a:r>
+              <a:rPr lang="en-US" sz="4600" dirty="0"/>
+              <a:t>N</a:t>
+            </a:r>
+            <a:r>
+              <a:rPr lang="en-US" sz="4600"/>
+              <a:t>eed</a:t>
+            </a:r>
+            <a:r>
+              <a:rPr lang="en-US" sz="4600" dirty="0"/>
+              <a:t>…</a:t>
             </a:r>
           </a:p>
         </p:txBody>

</xml_diff>